<commit_message>
Deck and landing show the whole car park; 40 drivers by default in the tracker's many-drivers check; the tracker's counts are YOLO26m, the browser's YOLO26n
Co-Authored-By: Claude Opus 5.5 <noreply@anthropic.com>
</commit_message>
<xml_diff>
--- a/deck/OQIM_defence.pptx
+++ b/deck/OQIM_defence.pptx
@@ -117,41 +117,41 @@
   <p:extLst>
     <p:ext uri="{521415D9-36F7-43E2-AB2F-B90AF26B5E84}">
       <p14:sectionLst xmlns:p14="http://schemas.microsoft.com/office/powerpoint/2010/main">
-        <p14:section name="Opening" id="{273911b4-a0fd-7a2e-f48e-930a251f2390}">
+        <p14:section name="Opening" id="{6c30e8aa-4d96-1647-de35-76bd498e6a06}">
           <p14:sldIdLst>
             <p14:sldId id="256"/>
           </p14:sldIdLst>
         </p14:section>
-        <p14:section name="Problem" id="{07931a80-40c9-bef6-7d63-badf83ba6490}">
+        <p14:section name="Problem" id="{1538b915-0489-c009-eea5-b248c5477339}">
           <p14:sldIdLst>
             <p14:sldId id="257"/>
           </p14:sldIdLst>
         </p14:section>
-        <p14:section name="Product and demo" id="{1b8caadb-dd8c-e4d7-d96a-1be4227721aa}">
+        <p14:section name="Product and demo" id="{c5e9f799-8513-b658-bebf-2e619e5d17ee}">
           <p14:sldIdLst>
             <p14:sldId id="258"/>
             <p14:sldId id="259"/>
             <p14:sldId id="260"/>
           </p14:sldIdLst>
         </p14:section>
-        <p14:section name="Technology" id="{4d032568-9297-ce69-3ef4-dee4c14d8216}">
+        <p14:section name="Technology" id="{dbe0b7f9-407c-97cd-5fb2-20902741f1d7}">
           <p14:sldIdLst>
             <p14:sldId id="261"/>
           </p14:sldIdLst>
         </p14:section>
-        <p14:section name="Business" id="{ffb35571-7ca7-b8fc-022b-e4ace6df2c34}">
+        <p14:section name="Business" id="{3c9aac2e-3dd0-c276-7032-f0a85ed1b08f}">
           <p14:sldIdLst>
             <p14:sldId id="262"/>
             <p14:sldId id="263"/>
           </p14:sldIdLst>
         </p14:section>
-        <p14:section name="Next stage" id="{28cd608c-fbb7-5324-5874-b15a5cd6e08d}">
+        <p14:section name="Next stage" id="{0b1491ea-4df0-8d8a-d7e1-2cc58fc8e0cc}">
           <p14:sldIdLst>
             <p14:sldId id="264"/>
             <p14:sldId id="265"/>
           </p14:sldIdLst>
         </p14:section>
-        <p14:section name="Team" id="{4d3cd335-4982-a682-ba83-37d2fd1ccd90}">
+        <p14:section name="Team" id="{c33404a3-e51d-5382-abf0-6a5462fb9758}">
           <p14:sldIdLst>
             <p14:sldId id="266"/>
           </p14:sldIdLst>
@@ -560,7 +560,7 @@
           <a:p>
             <a:r>
               <a:rPr lang="en-US" dirty="0"/>
-              <a:t>0:10. Good morning. We are team PariVision from Webster University in Tashkent. Our mode is Startup (say it out loud, the rules ask for it). OQIM is a parking tracker. Cameras over a car park count the free spaces, see cars come in and leave, forecast the free spaces for the minute you arrive, and tell each driver which car park to go to. On the right: a real car park at 09:04, 6 free spaces of 100.</a:t>
+              <a:t>0:10. Good morning. We are team PariVision from Webster University in Tashkent. Our mode is Startup (say it out loud, the rules ask for it). OQIM is a parking tracker. Cameras over a car park count the free spaces, see cars come in and leave, forecast the free spaces for the minute you arrive, and tell each driver which car park to go to. On the right: a real car park at 09:04, 29 free spaces of 153.</a:t>
             </a:r>
             <a:endParaRPr lang="en-US" dirty="0"/>
           </a:p>
@@ -912,7 +912,7 @@
           <a:p>
             <a:r>
               <a:rPr lang="en-US" dirty="0"/>
-              <a:t>1:40, live. Open https://oqim-audit.vercel.app/tracker. These are 3 real car park cameras from the PKLot dataset: PUCPR with 100 spaces, UFPR05 with 40 spaces, UFPR04 with 28 spaces, one morning each from 06:55 to 10:35. Press play. Every space is marked free or taken from the camera frame; when a space turns taken, a car came in, when it turns free, a car left. Over 112 frames, 98.8% of 6,844 space readings match the dataset's hand labels. The free count is off by a median of 1 spaces, 4 at the 90th percentile. The tracker saw 146 cars come in and 11 leave. The forecast for 10 minutes ahead is off by 3.0 spaces on average, against 4.6 for "same as now", over 101 forecasts. Then pick an arrival time and show which car park the tracker advises.</a:t>
+              <a:t>1:40, live. Open https://oqim-audit.vercel.app/tracker. These are 3 real car park cameras from the PKLot dataset: PUCPR with 100 spaces, UFPR05 with 40 spaces, UFPR04 with 28 spaces, one morning each from 06:55 to 10:35. Press play. Every space is marked free or taken from the camera frame; when a space turns taken, a car came in, when it turns free, a car left. Over 112 frames, 98.8% of 6,844 space readings match the dataset's hand labels. The free count is off by a median of 1 spaces, 4 at the 90th percentile. The tracker saw 146 cars come in and 11 leave. The forecast for 10 minutes ahead is off by 3.0 spaces on average, against 4.6 for "same as now", over 101 forecasts. The dataset labels only part of each car park, so the tracker also finds the rest: wherever a car stays in one place for 20 minutes is a space. That adds 86 spaces to the 168 labelled ones, and on the labelled part the same method finds 125 of the 142 spaces cars used. Then pick an arrival time and show which car park the tracker advises, and set 40 drivers asking at once: the navigator sends all of them to the nearest car park, the tracker spreads them.</a:t>
             </a:r>
             <a:endParaRPr lang="en-US" dirty="0"/>
           </a:p>
@@ -1000,7 +1000,7 @@
           <a:p>
             <a:r>
               <a:rPr lang="en-US" dirty="0"/>
-              <a:t>0:30. The detector itself, measured on images we did not tune on. 240 held-out PKLot images, 13,447 spaces: 97.4% right. When it calls a space taken it is right 99.1% of the time, and it finds 95.3% of the taken spaces. Sunny 97.0%, cloudy 99.0%, rainy 96.1%. The free count per image is off by a median of 0 spaces. Be honest: PKLot has no night frames, so night is not measured. It runs in the browser on /parking; YOLO26n, the same model as the tracker.</a:t>
+              <a:t>0:30. The detector itself, measured on images we did not tune on. 240 held-out PKLot images, 13,447 spaces: 97.4% right. When it calls a space taken it is right 99.1% of the time, and it finds 95.3% of the taken spaces. Sunny 97.0%, cloudy 99.0%, rainy 96.1%. The free count per image is off by a median of 0 spaces. Be honest: PKLot has no night frames, so night is not measured. It runs in the browser on /parking with YOLO26n; the tracker's counts use the larger YOLO26m with the same rule.</a:t>
             </a:r>
             <a:endParaRPr lang="en-US" dirty="0"/>
           </a:p>
@@ -1176,7 +1176,7 @@
           <a:p>
             <a:r>
               <a:rPr lang="en-US" dirty="0"/>
-              <a:t>0:40. For each car park camera: one frame every 5 minutes, from an ordinary fixed camera. The spaces are outlined once per camera. YOLO26n, 10 MB, finds cars, buses and trucks on the whole frame and on 3 by 3 tiles at 960 pixels, so small cars at the back are not missed. A space is taken when one box covers 40% of it, and it changes state only when two frames in a row agree, which removes most flicker. From the states we get the free count and every car in and out. The forecast takes the spaces taken now and adds the trend: half from the last 20 minutes, half from the car park's typical weekday morning, from the PKLot labels of its other weekdays. It is checked against the hand labels of the frame that many minutes later. The advice is the district model: drivers placed one by one, counting the ones already sent. The detector runs in ONNX Runtime Web, on WebGPU or WebAssembly; no GPU server, no number plates or faces read. Detector and worker are reused from our elimination system, and we say so.</a:t>
+              <a:t>0:40. For each car park camera: one frame every 5 minutes, from an ordinary fixed camera. The labelled spaces come with the dataset; the rest of the car park is found where a car stays in one place for 20 minutes. YOLO26m on the tracker frames, and the 10 MB YOLO26n in the browser on /parking, find cars, buses and trucks on the whole frame and on 3 by 3 tiles at 960 pixels, so small cars at the back are not missed. A space is taken when one box covers 40% of it, and it changes state only when two frames in a row agree, which removes most flicker. From the states we get the free count and every car in and out. The forecast takes the spaces taken now and adds the trend: half from the last 20 minutes, half from the car park's typical weekday morning, from the PKLot labels of its other weekdays. It is checked against the hand labels of the frame that many minutes later. The advice is the district model: drivers placed one by one, counting the ones already sent. The detector runs in ONNX Runtime Web, on WebGPU or WebAssembly; no GPU server, no number plates or faces read. Detector and worker are reused from our elimination system, and we say so.</a:t>
             </a:r>
             <a:endParaRPr lang="en-US" dirty="0"/>
           </a:p>
@@ -2762,7 +2762,7 @@
                 <a:ea typeface="Calibri" pitchFamily="34" charset="-122"/>
                 <a:cs typeface="Calibri" pitchFamily="34" charset="-120"/>
               </a:rPr>
-              <a:t>The PUCPR car park camera at 09:04 on 17 October 2012 (PKLot dataset). Green: free, red: taken, as our detector read the frame.</a:t>
+              <a:t>The PUCPR car park camera at 09:04 on 17 October 2012 (PKLot dataset). Green: free, red: taken, as our detector read the frame; dashed: spaces the camera found outside the hand labels.</a:t>
             </a:r>
             <a:endParaRPr lang="en-US" sz="1100" dirty="0"/>
           </a:p>
@@ -2903,7 +2903,7 @@
                 <a:ea typeface="Arial" pitchFamily="34" charset="-122"/>
                 <a:cs typeface="Arial" pitchFamily="34" charset="-120"/>
               </a:rPr>
-              <a:t>6 free of 100</a:t>
+              <a:t>29 free of 153</a:t>
             </a:r>
             <a:endParaRPr lang="en-US" sz="1300" dirty="0"/>
           </a:p>
@@ -6767,7 +6767,7 @@
                 <a:ea typeface="Arial" pitchFamily="34" charset="-122"/>
                 <a:cs typeface="Arial" pitchFamily="34" charset="-120"/>
               </a:rPr>
-              <a:t>146 in, 11 out</a:t>
+              <a:t>+86 spaces</a:t>
             </a:r>
             <a:endParaRPr lang="en-US" sz="2800" dirty="0"/>
           </a:p>
@@ -6806,7 +6806,7 @@
                 <a:ea typeface="Calibri" pitchFamily="34" charset="-122"/>
                 <a:cs typeface="Calibri" pitchFamily="34" charset="-120"/>
               </a:rPr>
-              <a:t>cars seen coming in and leaving</a:t>
+              <a:t>whole car park: found where cars stay; 146 cars in, 11 out</a:t>
             </a:r>
             <a:endParaRPr lang="en-US" sz="1300" dirty="0"/>
           </a:p>
@@ -8849,7 +8849,7 @@
                 <a:ea typeface="Calibri" pitchFamily="34" charset="-122"/>
                 <a:cs typeface="Calibri" pitchFamily="34" charset="-120"/>
               </a:rPr>
-              <a:t>One frame every 5 min from an ordinary fixed camera. The spaces are outlined once per camera.</a:t>
+              <a:t>One frame every 5 min from an ordinary fixed camera. Labelled spaces, plus the ones found where cars stay 20 minutes.</a:t>
             </a:r>
             <a:endParaRPr lang="en-US" sz="1400" dirty="0"/>
           </a:p>
@@ -8974,7 +8974,7 @@
                 <a:ea typeface="Calibri" pitchFamily="34" charset="-122"/>
                 <a:cs typeface="Calibri" pitchFamily="34" charset="-120"/>
               </a:rPr>
-              <a:t>YOLO26n (10 MB), whole frame plus 3 x 3 tiles at 960 px. Cars, buses and trucks.</a:t>
+              <a:t>YOLO26m on the tracker frames, YOLO26n (10 MB) in the browser; whole frame plus 3 x 3 tiles at 960 px.</a:t>
             </a:r>
             <a:endParaRPr lang="en-US" sz="1400" dirty="0"/>
           </a:p>

</xml_diff>

<commit_message>
Tracker finds the far rows too: 5 x 5 enlarged tiles over the top of the frame, looser matching for small boxes (198 spaces found outside the labels; 139 of the 142 labelled spaces cars used found the same way)
Co-Authored-By: Claude Opus 5.5 <noreply@anthropic.com>
</commit_message>
<xml_diff>
--- a/deck/OQIM_defence.pptx
+++ b/deck/OQIM_defence.pptx
@@ -117,41 +117,41 @@
   <p:extLst>
     <p:ext uri="{521415D9-36F7-43E2-AB2F-B90AF26B5E84}">
       <p14:sectionLst xmlns:p14="http://schemas.microsoft.com/office/powerpoint/2010/main">
-        <p14:section name="Opening" id="{6c30e8aa-4d96-1647-de35-76bd498e6a06}">
+        <p14:section name="Opening" id="{edbedeb6-5c38-a7a0-1da0-44398595ba30}">
           <p14:sldIdLst>
             <p14:sldId id="256"/>
           </p14:sldIdLst>
         </p14:section>
-        <p14:section name="Problem" id="{1538b915-0489-c009-eea5-b248c5477339}">
+        <p14:section name="Problem" id="{f8c59bc8-33a0-2f16-3a5f-aabefc372035}">
           <p14:sldIdLst>
             <p14:sldId id="257"/>
           </p14:sldIdLst>
         </p14:section>
-        <p14:section name="Product and demo" id="{c5e9f799-8513-b658-bebf-2e619e5d17ee}">
+        <p14:section name="Product and demo" id="{7dcedba0-12a1-319a-59cb-f8cf41ca8747}">
           <p14:sldIdLst>
             <p14:sldId id="258"/>
             <p14:sldId id="259"/>
             <p14:sldId id="260"/>
           </p14:sldIdLst>
         </p14:section>
-        <p14:section name="Technology" id="{dbe0b7f9-407c-97cd-5fb2-20902741f1d7}">
+        <p14:section name="Technology" id="{2315e715-b57e-da23-a973-7fe49fdef9aa}">
           <p14:sldIdLst>
             <p14:sldId id="261"/>
           </p14:sldIdLst>
         </p14:section>
-        <p14:section name="Business" id="{3c9aac2e-3dd0-c276-7032-f0a85ed1b08f}">
+        <p14:section name="Business" id="{8c58c8cf-ed59-7357-8b80-2de3a431ed6d}">
           <p14:sldIdLst>
             <p14:sldId id="262"/>
             <p14:sldId id="263"/>
           </p14:sldIdLst>
         </p14:section>
-        <p14:section name="Next stage" id="{0b1491ea-4df0-8d8a-d7e1-2cc58fc8e0cc}">
+        <p14:section name="Next stage" id="{6c6345ed-1c33-6313-c735-689819fb989e}">
           <p14:sldIdLst>
             <p14:sldId id="264"/>
             <p14:sldId id="265"/>
           </p14:sldIdLst>
         </p14:section>
-        <p14:section name="Team" id="{c33404a3-e51d-5382-abf0-6a5462fb9758}">
+        <p14:section name="Team" id="{b9ea5ece-5673-cb1c-b3ec-205fd6b603b5}">
           <p14:sldIdLst>
             <p14:sldId id="266"/>
           </p14:sldIdLst>
@@ -560,7 +560,7 @@
           <a:p>
             <a:r>
               <a:rPr lang="en-US" dirty="0"/>
-              <a:t>0:10. Good morning. We are team PariVision from Webster University in Tashkent. Our mode is Startup (say it out loud, the rules ask for it). OQIM is a parking tracker. Cameras over a car park count the free spaces, see cars come in and leave, forecast the free spaces for the minute you arrive, and tell each driver which car park to go to. On the right: a real car park at 09:04, 29 free spaces of 153.</a:t>
+              <a:t>0:10. Good morning. We are team PariVision from Webster University in Tashkent. Our mode is Startup (say it out loud, the rules ask for it). OQIM is a parking tracker. Cameras over a car park count the free spaces, see cars come in and leave, forecast the free spaces for the minute you arrive, and tell each driver which car park to go to. On the right: a real car park at 09:04, 55 free spaces of 260.</a:t>
             </a:r>
             <a:endParaRPr lang="en-US" dirty="0"/>
           </a:p>
@@ -912,7 +912,7 @@
           <a:p>
             <a:r>
               <a:rPr lang="en-US" dirty="0"/>
-              <a:t>1:40, live. Open https://oqim-audit.vercel.app/tracker. These are 3 real car park cameras from the PKLot dataset: PUCPR with 100 spaces, UFPR05 with 40 spaces, UFPR04 with 28 spaces, one morning each from 06:55 to 10:35. Press play. Every space is marked free or taken from the camera frame; when a space turns taken, a car came in, when it turns free, a car left. Over 112 frames, 98.8% of 6,844 space readings match the dataset's hand labels. The free count is off by a median of 1 spaces, 4 at the 90th percentile. The tracker saw 146 cars come in and 11 leave. The forecast for 10 minutes ahead is off by 3.0 spaces on average, against 4.6 for "same as now", over 101 forecasts. The dataset labels only part of each car park, so the tracker also finds the rest: wherever a car stays in one place for 20 minutes is a space. That adds 86 spaces to the 168 labelled ones, and on the labelled part the same method finds 125 of the 142 spaces cars used. Then pick an arrival time and show which car park the tracker advises, and set 40 drivers asking at once: the navigator sends all of them to the nearest car park, the tracker spreads them.</a:t>
+              <a:t>1:40, live. Open https://oqim-audit.vercel.app/tracker. These are 3 real car park cameras from the PKLot dataset: PUCPR with 100 spaces, UFPR05 with 40 spaces, UFPR04 with 28 spaces, one morning each from 06:55 to 10:35. Press play. Every space is marked free or taken from the camera frame; when a space turns taken, a car came in, when it turns free, a car left. Over 112 frames, 98.8% of 6,844 space readings match the dataset's hand labels. The free count is off by a median of 1 spaces, 4 at the 90th percentile. The tracker saw 146 cars come in and 11 leave. The forecast for 10 minutes ahead is off by 3.0 spaces on average, against 4.6 for "same as now", over 101 forecasts. The dataset labels only part of each car park, so the tracker also finds the rest: wherever a car stays in one place for 20 minutes is a space. That adds 198 spaces to the 168 labelled ones, and on the labelled part the same method finds 139 of the 142 spaces cars used. Then pick an arrival time and show which car park the tracker advises, and set 40 drivers asking at once: the navigator sends all of them to the nearest car park, the tracker spreads them.</a:t>
             </a:r>
             <a:endParaRPr lang="en-US" dirty="0"/>
           </a:p>
@@ -2903,7 +2903,7 @@
                 <a:ea typeface="Arial" pitchFamily="34" charset="-122"/>
                 <a:cs typeface="Arial" pitchFamily="34" charset="-120"/>
               </a:rPr>
-              <a:t>29 free of 153</a:t>
+              <a:t>55 free of 260</a:t>
             </a:r>
             <a:endParaRPr lang="en-US" sz="1300" dirty="0"/>
           </a:p>
@@ -6767,7 +6767,7 @@
                 <a:ea typeface="Arial" pitchFamily="34" charset="-122"/>
                 <a:cs typeface="Arial" pitchFamily="34" charset="-120"/>
               </a:rPr>
-              <a:t>+86 spaces</a:t>
+              <a:t>+198 spaces</a:t>
             </a:r>
             <a:endParaRPr lang="en-US" sz="2800" dirty="0"/>
           </a:p>

</xml_diff>